<commit_message>
Adiciona slide 13 de agradecimento e obrigado
</commit_message>
<xml_diff>
--- a/relatorio/ApresentacaoEcoCity.pptx
+++ b/relatorio/ApresentacaoEcoCity.pptx
@@ -17,6 +17,7 @@
     <p:sldId id="265" r:id="rId16"/>
     <p:sldId id="266" r:id="rId17"/>
     <p:sldId id="267" r:id="rId18"/>
+    <p:sldId id="268" r:id="rId19"/>
   </p:sldIdLst>
   <p:sldSz cx="9144000" cy="6858000" type="screen4x3"/>
   <p:notesSz cx="6858000" cy="9144000"/>
@@ -4980,7 +4981,7 @@
                 </a:solidFill>
                 <a:latin typeface="Calibri"/>
               </a:rPr>
-              <a:t>10 / 12</a:t>
+              <a:t>10 / 13</a:t>
             </a:r>
           </a:p>
         </p:txBody>
@@ -6700,7 +6701,7 @@
                 </a:solidFill>
                 <a:latin typeface="Calibri"/>
               </a:rPr>
-              <a:t>11 / 12</a:t>
+              <a:t>11 / 13</a:t>
             </a:r>
           </a:p>
         </p:txBody>
@@ -7207,13 +7208,13 @@
           <a:p>
             <a:pPr algn="l"/>
             <a:r>
-              <a:rPr sz="1400" b="0">
+              <a:rPr sz="1300" b="0">
                 <a:solidFill>
                   <a:srgbClr val="6AD18A"/>
                 </a:solidFill>
                 <a:latin typeface="Calibri"/>
               </a:rPr>
-              <a:t>Obrigado!  -  EcoCity, APS UNIP 2026/1.</a:t>
+              <a:t>Clone, fork ou download ZIP - codigo aberto.</a:t>
             </a:r>
           </a:p>
         </p:txBody>
@@ -7283,7 +7284,546 @@
                 </a:solidFill>
                 <a:latin typeface="Calibri"/>
               </a:rPr>
-              <a:t>12 / 12</a:t>
+              <a:t>12 / 13</a:t>
+            </a:r>
+          </a:p>
+        </p:txBody>
+      </p:sp>
+    </p:spTree>
+  </p:cSld>
+  <p:clrMapOvr>
+    <a:masterClrMapping/>
+  </p:clrMapOvr>
+</p:sld>
+</file>
+
+<file path=ppt/slides/slide13.xml><?xml version="1.0" encoding="utf-8"?>
+<p:sld xmlns:a="http://schemas.openxmlformats.org/drawingml/2006/main" xmlns:p="http://schemas.openxmlformats.org/presentationml/2006/main" xmlns:r="http://schemas.openxmlformats.org/officeDocument/2006/relationships">
+  <p:cSld>
+    <p:bg>
+      <p:bgPr>
+        <a:solidFill>
+          <a:srgbClr val="142A16"/>
+        </a:solidFill>
+        <a:effectLst/>
+      </p:bgPr>
+    </p:bg>
+    <p:spTree>
+      <p:nvGrpSpPr>
+        <p:cNvPr id="1" name=""/>
+        <p:cNvGrpSpPr/>
+        <p:nvPr/>
+      </p:nvGrpSpPr>
+      <p:grpSpPr/>
+      <p:sp>
+        <p:nvSpPr>
+          <p:cNvPr id="2" name="Oval 1"/>
+          <p:cNvSpPr/>
+          <p:nvPr/>
+        </p:nvSpPr>
+        <p:spPr>
+          <a:xfrm>
+            <a:off x="-1371600" y="-1371600"/>
+            <a:ext cx="4114800" cy="4114800"/>
+          </a:xfrm>
+          <a:prstGeom prst="ellipse">
+            <a:avLst/>
+          </a:prstGeom>
+          <a:solidFill>
+            <a:srgbClr val="2C5F2D"/>
+          </a:solidFill>
+          <a:ln>
+            <a:noFill/>
+          </a:ln>
+          <a:effectLst/>
+        </p:spPr>
+        <p:style>
+          <a:lnRef idx="1">
+            <a:schemeClr val="accent1"/>
+          </a:lnRef>
+          <a:fillRef idx="3">
+            <a:schemeClr val="accent1"/>
+          </a:fillRef>
+          <a:effectRef idx="2">
+            <a:schemeClr val="accent1"/>
+          </a:effectRef>
+          <a:fontRef idx="minor">
+            <a:schemeClr val="lt1"/>
+          </a:fontRef>
+        </p:style>
+        <p:txBody>
+          <a:bodyPr rtlCol="0" anchor="ctr"/>
+          <a:lstStyle/>
+          <a:p>
+            <a:pPr algn="ctr"/>
+          </a:p>
+        </p:txBody>
+      </p:sp>
+      <p:sp>
+        <p:nvSpPr>
+          <p:cNvPr id="3" name="Oval 2"/>
+          <p:cNvSpPr/>
+          <p:nvPr/>
+        </p:nvSpPr>
+        <p:spPr>
+          <a:xfrm>
+            <a:off x="-731520" y="-731520"/>
+            <a:ext cx="2743200" cy="2743200"/>
+          </a:xfrm>
+          <a:prstGeom prst="ellipse">
+            <a:avLst/>
+          </a:prstGeom>
+          <a:solidFill>
+            <a:srgbClr val="142A16"/>
+          </a:solidFill>
+          <a:ln>
+            <a:noFill/>
+          </a:ln>
+          <a:effectLst/>
+        </p:spPr>
+        <p:style>
+          <a:lnRef idx="1">
+            <a:schemeClr val="accent1"/>
+          </a:lnRef>
+          <a:fillRef idx="3">
+            <a:schemeClr val="accent1"/>
+          </a:fillRef>
+          <a:effectRef idx="2">
+            <a:schemeClr val="accent1"/>
+          </a:effectRef>
+          <a:fontRef idx="minor">
+            <a:schemeClr val="lt1"/>
+          </a:fontRef>
+        </p:style>
+        <p:txBody>
+          <a:bodyPr rtlCol="0" anchor="ctr"/>
+          <a:lstStyle/>
+          <a:p>
+            <a:pPr algn="ctr"/>
+          </a:p>
+        </p:txBody>
+      </p:sp>
+      <p:sp>
+        <p:nvSpPr>
+          <p:cNvPr id="4" name="Oval 3"/>
+          <p:cNvSpPr/>
+          <p:nvPr/>
+        </p:nvSpPr>
+        <p:spPr>
+          <a:xfrm>
+            <a:off x="6858000" y="5029200"/>
+            <a:ext cx="4114800" cy="4114800"/>
+          </a:xfrm>
+          <a:prstGeom prst="ellipse">
+            <a:avLst/>
+          </a:prstGeom>
+          <a:solidFill>
+            <a:srgbClr val="2C5F2D"/>
+          </a:solidFill>
+          <a:ln>
+            <a:noFill/>
+          </a:ln>
+          <a:effectLst/>
+        </p:spPr>
+        <p:style>
+          <a:lnRef idx="1">
+            <a:schemeClr val="accent1"/>
+          </a:lnRef>
+          <a:fillRef idx="3">
+            <a:schemeClr val="accent1"/>
+          </a:fillRef>
+          <a:effectRef idx="2">
+            <a:schemeClr val="accent1"/>
+          </a:effectRef>
+          <a:fontRef idx="minor">
+            <a:schemeClr val="lt1"/>
+          </a:fontRef>
+        </p:style>
+        <p:txBody>
+          <a:bodyPr rtlCol="0" anchor="ctr"/>
+          <a:lstStyle/>
+          <a:p>
+            <a:pPr algn="ctr"/>
+          </a:p>
+        </p:txBody>
+      </p:sp>
+      <p:sp>
+        <p:nvSpPr>
+          <p:cNvPr id="5" name="Oval 4"/>
+          <p:cNvSpPr/>
+          <p:nvPr/>
+        </p:nvSpPr>
+        <p:spPr>
+          <a:xfrm>
+            <a:off x="7498079" y="5669280"/>
+            <a:ext cx="2743200" cy="2743200"/>
+          </a:xfrm>
+          <a:prstGeom prst="ellipse">
+            <a:avLst/>
+          </a:prstGeom>
+          <a:solidFill>
+            <a:srgbClr val="142A16"/>
+          </a:solidFill>
+          <a:ln>
+            <a:noFill/>
+          </a:ln>
+          <a:effectLst/>
+        </p:spPr>
+        <p:style>
+          <a:lnRef idx="1">
+            <a:schemeClr val="accent1"/>
+          </a:lnRef>
+          <a:fillRef idx="3">
+            <a:schemeClr val="accent1"/>
+          </a:fillRef>
+          <a:effectRef idx="2">
+            <a:schemeClr val="accent1"/>
+          </a:effectRef>
+          <a:fontRef idx="minor">
+            <a:schemeClr val="lt1"/>
+          </a:fontRef>
+        </p:style>
+        <p:txBody>
+          <a:bodyPr rtlCol="0" anchor="ctr"/>
+          <a:lstStyle/>
+          <a:p>
+            <a:pPr algn="ctr"/>
+          </a:p>
+        </p:txBody>
+      </p:sp>
+      <p:sp>
+        <p:nvSpPr>
+          <p:cNvPr id="6" name="TextBox 5"/>
+          <p:cNvSpPr txBox="1"/>
+          <p:nvPr/>
+        </p:nvSpPr>
+        <p:spPr>
+          <a:xfrm>
+            <a:off x="914400" y="1463040"/>
+            <a:ext cx="8229600" cy="1828800"/>
+          </a:xfrm>
+          <a:prstGeom prst="rect">
+            <a:avLst/>
+          </a:prstGeom>
+          <a:noFill/>
+        </p:spPr>
+        <p:txBody>
+          <a:bodyPr wrap="square" lIns="0" rIns="0" tIns="0" bIns="0" anchor="t">
+            <a:spAutoFit/>
+          </a:bodyPr>
+          <a:lstStyle/>
+          <a:p>
+            <a:pPr algn="l"/>
+            <a:r>
+              <a:rPr sz="9600" b="1">
+                <a:solidFill>
+                  <a:srgbClr val="FFFFFF"/>
+                </a:solidFill>
+                <a:latin typeface="Calibri"/>
+              </a:rPr>
+              <a:t>Obrigado!</a:t>
+            </a:r>
+          </a:p>
+        </p:txBody>
+      </p:sp>
+      <p:sp>
+        <p:nvSpPr>
+          <p:cNvPr id="7" name="Rectangle 6"/>
+          <p:cNvSpPr/>
+          <p:nvPr/>
+        </p:nvSpPr>
+        <p:spPr>
+          <a:xfrm>
+            <a:off x="960120" y="2926080"/>
+            <a:ext cx="822960" cy="45720"/>
+          </a:xfrm>
+          <a:prstGeom prst="rect">
+            <a:avLst/>
+          </a:prstGeom>
+          <a:solidFill>
+            <a:srgbClr val="6AD18A"/>
+          </a:solidFill>
+          <a:ln>
+            <a:noFill/>
+          </a:ln>
+          <a:effectLst/>
+        </p:spPr>
+        <p:style>
+          <a:lnRef idx="1">
+            <a:schemeClr val="accent1"/>
+          </a:lnRef>
+          <a:fillRef idx="3">
+            <a:schemeClr val="accent1"/>
+          </a:fillRef>
+          <a:effectRef idx="2">
+            <a:schemeClr val="accent1"/>
+          </a:effectRef>
+          <a:fontRef idx="minor">
+            <a:schemeClr val="lt1"/>
+          </a:fontRef>
+        </p:style>
+        <p:txBody>
+          <a:bodyPr rtlCol="0" anchor="ctr"/>
+          <a:lstStyle/>
+          <a:p>
+            <a:pPr algn="ctr"/>
+          </a:p>
+        </p:txBody>
+      </p:sp>
+      <p:sp>
+        <p:nvSpPr>
+          <p:cNvPr id="8" name="TextBox 7"/>
+          <p:cNvSpPr txBox="1"/>
+          <p:nvPr/>
+        </p:nvSpPr>
+        <p:spPr>
+          <a:xfrm>
+            <a:off x="960120" y="3108960"/>
+            <a:ext cx="7772400" cy="548640"/>
+          </a:xfrm>
+          <a:prstGeom prst="rect">
+            <a:avLst/>
+          </a:prstGeom>
+          <a:noFill/>
+        </p:spPr>
+        <p:txBody>
+          <a:bodyPr wrap="square" lIns="0" rIns="0" tIns="0" bIns="0" anchor="t">
+            <a:spAutoFit/>
+          </a:bodyPr>
+          <a:lstStyle/>
+          <a:p>
+            <a:pPr algn="l"/>
+            <a:r>
+              <a:rPr sz="2000" b="0">
+                <a:solidFill>
+                  <a:srgbClr val="6AD18A"/>
+                </a:solidFill>
+                <a:latin typeface="Calibri"/>
+              </a:rPr>
+              <a:t>Pela atencao a apresentacao do projeto EcoCity.</a:t>
+            </a:r>
+          </a:p>
+        </p:txBody>
+      </p:sp>
+      <p:sp>
+        <p:nvSpPr>
+          <p:cNvPr id="9" name="TextBox 8"/>
+          <p:cNvSpPr txBox="1"/>
+          <p:nvPr/>
+        </p:nvSpPr>
+        <p:spPr>
+          <a:xfrm>
+            <a:off x="960120" y="3703320"/>
+            <a:ext cx="7772400" cy="457200"/>
+          </a:xfrm>
+          <a:prstGeom prst="rect">
+            <a:avLst/>
+          </a:prstGeom>
+          <a:noFill/>
+        </p:spPr>
+        <p:txBody>
+          <a:bodyPr wrap="square" lIns="0" rIns="0" tIns="0" bIns="0" anchor="t">
+            <a:spAutoFit/>
+          </a:bodyPr>
+          <a:lstStyle/>
+          <a:p>
+            <a:pPr algn="l"/>
+            <a:r>
+              <a:rPr sz="1400" b="0">
+                <a:solidFill>
+                  <a:srgbClr val="C8DAC0"/>
+                </a:solidFill>
+                <a:latin typeface="Calibri"/>
+              </a:rPr>
+              <a:t>Perguntas, sugestoes e ideias sao muito bem-vindas.</a:t>
+            </a:r>
+          </a:p>
+        </p:txBody>
+      </p:sp>
+      <p:sp>
+        <p:nvSpPr>
+          <p:cNvPr id="10" name="TextBox 9"/>
+          <p:cNvSpPr txBox="1"/>
+          <p:nvPr/>
+        </p:nvSpPr>
+        <p:spPr>
+          <a:xfrm>
+            <a:off x="960120" y="4572000"/>
+            <a:ext cx="1828800" cy="274320"/>
+          </a:xfrm>
+          <a:prstGeom prst="rect">
+            <a:avLst/>
+          </a:prstGeom>
+          <a:noFill/>
+        </p:spPr>
+        <p:txBody>
+          <a:bodyPr wrap="square" lIns="0" rIns="0" tIns="0" bIns="0" anchor="t">
+            <a:spAutoFit/>
+          </a:bodyPr>
+          <a:lstStyle/>
+          <a:p>
+            <a:pPr algn="l"/>
+            <a:r>
+              <a:rPr sz="1100" b="1">
+                <a:solidFill>
+                  <a:srgbClr val="6AD18A"/>
+                </a:solidFill>
+                <a:latin typeface="Calibri"/>
+              </a:rPr>
+              <a:t>GRUPO</a:t>
+            </a:r>
+          </a:p>
+        </p:txBody>
+      </p:sp>
+      <p:sp>
+        <p:nvSpPr>
+          <p:cNvPr id="11" name="TextBox 10"/>
+          <p:cNvSpPr txBox="1"/>
+          <p:nvPr/>
+        </p:nvSpPr>
+        <p:spPr>
+          <a:xfrm>
+            <a:off x="960120" y="4864608"/>
+            <a:ext cx="8229600" cy="1371600"/>
+          </a:xfrm>
+          <a:prstGeom prst="rect">
+            <a:avLst/>
+          </a:prstGeom>
+          <a:noFill/>
+        </p:spPr>
+        <p:txBody>
+          <a:bodyPr wrap="square" lIns="0" rIns="0" tIns="0" bIns="0" anchor="t">
+            <a:spAutoFit/>
+          </a:bodyPr>
+          <a:lstStyle/>
+          <a:p>
+            <a:pPr algn="l"/>
+            <a:r>
+              <a:rPr sz="1050" b="0">
+                <a:solidFill>
+                  <a:srgbClr val="FFFFFF"/>
+                </a:solidFill>
+                <a:latin typeface="Consolas"/>
+              </a:rPr>
+              <a:t>Alessandra Cristina da Silva Souza  -  R799565</a:t>
+            </a:r>
+          </a:p>
+          <a:p>
+            <a:pPr algn="l"/>
+            <a:r>
+              <a:rPr sz="1050" b="0">
+                <a:solidFill>
+                  <a:srgbClr val="FFFFFF"/>
+                </a:solidFill>
+                <a:latin typeface="Consolas"/>
+              </a:rPr>
+              <a:t>Caetano de Paula Telles Ribeiro     -  R688GC4</a:t>
+            </a:r>
+          </a:p>
+          <a:p>
+            <a:pPr algn="l"/>
+            <a:r>
+              <a:rPr sz="1050" b="0">
+                <a:solidFill>
+                  <a:srgbClr val="FFFFFF"/>
+                </a:solidFill>
+                <a:latin typeface="Consolas"/>
+              </a:rPr>
+              <a:t>Jhonnatan Pereira Santos            -  R363JH0</a:t>
+            </a:r>
+          </a:p>
+          <a:p>
+            <a:pPr algn="l"/>
+            <a:r>
+              <a:rPr sz="1050" b="0">
+                <a:solidFill>
+                  <a:srgbClr val="FFFFFF"/>
+                </a:solidFill>
+                <a:latin typeface="Consolas"/>
+              </a:rPr>
+              <a:t>Guilherme Moraes Franco             -  H386632</a:t>
+            </a:r>
+          </a:p>
+          <a:p>
+            <a:pPr algn="l"/>
+            <a:r>
+              <a:rPr sz="1050" b="0">
+                <a:solidFill>
+                  <a:srgbClr val="FFFFFF"/>
+                </a:solidFill>
+                <a:latin typeface="Consolas"/>
+              </a:rPr>
+              <a:t>Gabriel Moraes Franco               -  H384338</a:t>
+            </a:r>
+          </a:p>
+        </p:txBody>
+      </p:sp>
+      <p:sp>
+        <p:nvSpPr>
+          <p:cNvPr id="12" name="TextBox 11"/>
+          <p:cNvSpPr txBox="1"/>
+          <p:nvPr/>
+        </p:nvSpPr>
+        <p:spPr>
+          <a:xfrm>
+            <a:off x="457200" y="6446520"/>
+            <a:ext cx="8686800" cy="274320"/>
+          </a:xfrm>
+          <a:prstGeom prst="rect">
+            <a:avLst/>
+          </a:prstGeom>
+          <a:noFill/>
+        </p:spPr>
+        <p:txBody>
+          <a:bodyPr wrap="square" lIns="0" rIns="0" tIns="0" bIns="0" anchor="t">
+            <a:spAutoFit/>
+          </a:bodyPr>
+          <a:lstStyle/>
+          <a:p>
+            <a:pPr algn="l"/>
+            <a:r>
+              <a:rPr sz="900" b="0">
+                <a:solidFill>
+                  <a:srgbClr val="9BB0A0"/>
+                </a:solidFill>
+                <a:latin typeface="Calibri"/>
+              </a:rPr>
+              <a:t>EcoCity  -  RPG Textual  |  APS UNIP 2026/1  -  LPOO</a:t>
+            </a:r>
+          </a:p>
+        </p:txBody>
+      </p:sp>
+      <p:sp>
+        <p:nvSpPr>
+          <p:cNvPr id="13" name="TextBox 12"/>
+          <p:cNvSpPr txBox="1"/>
+          <p:nvPr/>
+        </p:nvSpPr>
+        <p:spPr>
+          <a:xfrm>
+            <a:off x="8503920" y="6446520"/>
+            <a:ext cx="731520" cy="274320"/>
+          </a:xfrm>
+          <a:prstGeom prst="rect">
+            <a:avLst/>
+          </a:prstGeom>
+          <a:noFill/>
+        </p:spPr>
+        <p:txBody>
+          <a:bodyPr wrap="square" lIns="0" rIns="0" tIns="0" bIns="0" anchor="t">
+            <a:spAutoFit/>
+          </a:bodyPr>
+          <a:lstStyle/>
+          <a:p>
+            <a:pPr algn="r"/>
+            <a:r>
+              <a:rPr sz="900" b="0">
+                <a:solidFill>
+                  <a:srgbClr val="9BB0A0"/>
+                </a:solidFill>
+                <a:latin typeface="Calibri"/>
+              </a:rPr>
+              <a:t>13 / 13</a:t>
             </a:r>
           </a:p>
         </p:txBody>
@@ -8633,7 +9173,7 @@
                 </a:solidFill>
                 <a:latin typeface="Calibri"/>
               </a:rPr>
-              <a:t>2 / 12</a:t>
+              <a:t>2 / 13</a:t>
             </a:r>
           </a:p>
         </p:txBody>
@@ -9549,7 +10089,7 @@
                 </a:solidFill>
                 <a:latin typeface="Calibri"/>
               </a:rPr>
-              <a:t>3 / 12</a:t>
+              <a:t>3 / 13</a:t>
             </a:r>
           </a:p>
         </p:txBody>
@@ -10575,7 +11115,7 @@
                 </a:solidFill>
                 <a:latin typeface="Calibri"/>
               </a:rPr>
-              <a:t>4 / 12</a:t>
+              <a:t>4 / 13</a:t>
             </a:r>
           </a:p>
         </p:txBody>
@@ -11565,7 +12105,7 @@
                 </a:solidFill>
                 <a:latin typeface="Calibri"/>
               </a:rPr>
-              <a:t>5 / 12</a:t>
+              <a:t>5 / 13</a:t>
             </a:r>
           </a:p>
         </p:txBody>
@@ -12785,7 +13325,7 @@
                 </a:solidFill>
                 <a:latin typeface="Calibri"/>
               </a:rPr>
-              <a:t>6 / 12</a:t>
+              <a:t>6 / 13</a:t>
             </a:r>
           </a:p>
         </p:txBody>
@@ -13814,7 +14354,7 @@
                 </a:solidFill>
                 <a:latin typeface="Calibri"/>
               </a:rPr>
-              <a:t>7 / 12</a:t>
+              <a:t>7 / 13</a:t>
             </a:r>
           </a:p>
         </p:txBody>
@@ -14688,7 +15228,7 @@
                 </a:solidFill>
                 <a:latin typeface="Calibri"/>
               </a:rPr>
-              <a:t>8 / 12</a:t>
+              <a:t>8 / 13</a:t>
             </a:r>
           </a:p>
         </p:txBody>
@@ -15698,7 +16238,7 @@
                 </a:solidFill>
                 <a:latin typeface="Calibri"/>
               </a:rPr>
-              <a:t>9 / 12</a:t>
+              <a:t>9 / 13</a:t>
             </a:r>
           </a:p>
         </p:txBody>

</xml_diff>

<commit_message>
Remove rodape e enxuga slides 10-12 (codigo)
- Remove o rodape "EcoCity - RPG Textual | APS UNIP 2026/1 - LPOO"
  de todos os slides
- Estrutura do Codigo: descricoes curtas dos pacotes
- Conceitos e Hierarquia: labels limpas, sem nota auxiliar
- Codigo e Entrega: titulo e snippet menores para falar menos
</commit_message>
<xml_diff>
--- a/relatorio/ApresentacaoEcoCity.pptx
+++ b/relatorio/ApresentacaoEcoCity.pptx
@@ -3791,7 +3791,7 @@
                 </a:solidFill>
                 <a:latin typeface="Calibri"/>
               </a:rPr>
-              <a:t>14 arquivos .java organizados em 7 pacotes - cada um com 1 responsabilidade</a:t>
+              <a:t>14 arquivos .java em 7 pacotes</a:t>
             </a:r>
           </a:p>
         </p:txBody>
@@ -3951,7 +3951,7 @@
                 </a:solidFill>
                 <a:latin typeface="Calibri"/>
               </a:rPr>
-              <a:t>ponto de entrada do jogo (menu)</a:t>
+              <a:t>ponto de entrada</a:t>
             </a:r>
           </a:p>
         </p:txBody>
@@ -4111,7 +4111,7 @@
                 </a:solidFill>
                 <a:latin typeface="Calibri"/>
               </a:rPr>
-              <a:t>Terminal: limpa tela + aguarda ENTER</a:t>
+              <a:t>tela e entrada</a:t>
             </a:r>
           </a:p>
         </p:txBody>
@@ -4271,7 +4271,7 @@
                 </a:solidFill>
                 <a:latin typeface="Calibri"/>
               </a:rPr>
-              <a:t>Personagem (abstrata) + 5 niveis</a:t>
+              <a:t>Personagem + 5 niveis</a:t>
             </a:r>
           </a:p>
         </p:txBody>
@@ -4431,7 +4431,7 @@
                 </a:solidFill>
                 <a:latin typeface="Calibri"/>
               </a:rPr>
-              <a:t>Interface Missao + MissaoEcologica</a:t>
+              <a:t>interface + missao</a:t>
             </a:r>
           </a:p>
         </p:txBody>
@@ -4591,7 +4591,7 @@
                 </a:solidFill>
                 <a:latin typeface="Calibri"/>
               </a:rPr>
-              <a:t>NPC entrega missoes ao jogador</a:t>
+              <a:t>entrega missoes</a:t>
             </a:r>
           </a:p>
         </p:txBody>
@@ -4751,7 +4751,7 @@
                 </a:solidFill>
                 <a:latin typeface="Calibri"/>
               </a:rPr>
-              <a:t>Jogo (orquestra) + Pontuacao (calcula)</a:t>
+              <a:t>Jogo + Pontuacao</a:t>
             </a:r>
           </a:p>
         </p:txBody>
@@ -4911,7 +4911,7 @@
                 </a:solidFill>
                 <a:latin typeface="Calibri"/>
               </a:rPr>
-              <a:t>EntradaInvalidaException (customizada)</a:t>
+              <a:t>excecao customizada</a:t>
             </a:r>
           </a:p>
         </p:txBody>
@@ -4919,41 +4919,6 @@
       <p:sp>
         <p:nvSpPr>
           <p:cNvPr id="34" name="TextBox 33"/>
-          <p:cNvSpPr txBox="1"/>
-          <p:nvPr/>
-        </p:nvSpPr>
-        <p:spPr>
-          <a:xfrm>
-            <a:off x="457200" y="6446520"/>
-            <a:ext cx="8686800" cy="274320"/>
-          </a:xfrm>
-          <a:prstGeom prst="rect">
-            <a:avLst/>
-          </a:prstGeom>
-          <a:noFill/>
-        </p:spPr>
-        <p:txBody>
-          <a:bodyPr wrap="square" lIns="0" rIns="0" tIns="0" bIns="0" anchor="t">
-            <a:spAutoFit/>
-          </a:bodyPr>
-          <a:lstStyle/>
-          <a:p>
-            <a:pPr algn="l"/>
-            <a:r>
-              <a:rPr sz="900" b="0">
-                <a:solidFill>
-                  <a:srgbClr val="6E7C71"/>
-                </a:solidFill>
-                <a:latin typeface="Calibri"/>
-              </a:rPr>
-              <a:t>EcoCity  -  RPG Textual  |  APS UNIP 2026/1  -  LPOO</a:t>
-            </a:r>
-          </a:p>
-        </p:txBody>
-      </p:sp>
-      <p:sp>
-        <p:nvSpPr>
-          <p:cNvPr id="35" name="TextBox 34"/>
           <p:cNvSpPr txBox="1"/>
           <p:nvPr/>
         </p:nvSpPr>
@@ -5472,7 +5437,7 @@
                 </a:solidFill>
                 <a:latin typeface="Calibri"/>
               </a:rPr>
-              <a:t>Sobrecarga (overload)</a:t>
+              <a:t>Sobrecarga</a:t>
             </a:r>
           </a:p>
         </p:txBody>
@@ -5551,7 +5516,7 @@
                 </a:solidFill>
                 <a:latin typeface="Calibri"/>
               </a:rPr>
-              <a:t>Sobrescrita (override)</a:t>
+              <a:t>Sobrescrita</a:t>
             </a:r>
           </a:p>
         </p:txBody>
@@ -5867,7 +5832,7 @@
                 </a:solidFill>
                 <a:latin typeface="Calibri"/>
               </a:rPr>
-              <a:t>Tratamento de Excecoes</a:t>
+              <a:t>Excecoes</a:t>
             </a:r>
           </a:p>
         </p:txBody>
@@ -6604,76 +6569,6 @@
       <p:sp>
         <p:nvSpPr>
           <p:cNvPr id="43" name="TextBox 42"/>
-          <p:cNvSpPr txBox="1"/>
-          <p:nvPr/>
-        </p:nvSpPr>
-        <p:spPr>
-          <a:xfrm>
-            <a:off x="4709160" y="5806440"/>
-            <a:ext cx="3840480" cy="365760"/>
-          </a:xfrm>
-          <a:prstGeom prst="rect">
-            <a:avLst/>
-          </a:prstGeom>
-          <a:noFill/>
-        </p:spPr>
-        <p:txBody>
-          <a:bodyPr wrap="square" lIns="0" rIns="0" tIns="0" bIns="0" anchor="t">
-            <a:spAutoFit/>
-          </a:bodyPr>
-          <a:lstStyle/>
-          <a:p>
-            <a:pPr algn="ctr"/>
-            <a:r>
-              <a:rPr sz="1000" b="0">
-                <a:solidFill>
-                  <a:srgbClr val="6E7C71"/>
-                </a:solidFill>
-                <a:latin typeface="Calibri"/>
-              </a:rPr>
-              <a:t>5 subclasses herdam de Personagem (abstrata).</a:t>
-            </a:r>
-          </a:p>
-        </p:txBody>
-      </p:sp>
-      <p:sp>
-        <p:nvSpPr>
-          <p:cNvPr id="44" name="TextBox 43"/>
-          <p:cNvSpPr txBox="1"/>
-          <p:nvPr/>
-        </p:nvSpPr>
-        <p:spPr>
-          <a:xfrm>
-            <a:off x="457200" y="6446520"/>
-            <a:ext cx="8686800" cy="274320"/>
-          </a:xfrm>
-          <a:prstGeom prst="rect">
-            <a:avLst/>
-          </a:prstGeom>
-          <a:noFill/>
-        </p:spPr>
-        <p:txBody>
-          <a:bodyPr wrap="square" lIns="0" rIns="0" tIns="0" bIns="0" anchor="t">
-            <a:spAutoFit/>
-          </a:bodyPr>
-          <a:lstStyle/>
-          <a:p>
-            <a:pPr algn="l"/>
-            <a:r>
-              <a:rPr sz="900" b="0">
-                <a:solidFill>
-                  <a:srgbClr val="6E7C71"/>
-                </a:solidFill>
-                <a:latin typeface="Calibri"/>
-              </a:rPr>
-              <a:t>EcoCity  -  RPG Textual  |  APS UNIP 2026/1  -  LPOO</a:t>
-            </a:r>
-          </a:p>
-        </p:txBody>
-      </p:sp>
-      <p:sp>
-        <p:nvSpPr>
-          <p:cNvPr id="45" name="TextBox 44"/>
           <p:cNvSpPr txBox="1"/>
           <p:nvPr/>
         </p:nvSpPr>
@@ -6841,7 +6736,7 @@
                 </a:solidFill>
                 <a:latin typeface="Calibri"/>
               </a:rPr>
-              <a:t>Em Codigo  -  Entrega e Encerramento</a:t>
+              <a:t>Codigo e Entrega</a:t>
             </a:r>
           </a:p>
         </p:txBody>
@@ -6876,7 +6771,7 @@
                 </a:solidFill>
                 <a:latin typeface="Calibri"/>
               </a:rPr>
-              <a:t>EXEMPLO: TRATAMENTO DE EXCECAO NO MENU</a:t>
+              <a:t>EXEMPLO: try-catch no menu</a:t>
             </a:r>
           </a:p>
         </p:txBody>
@@ -6969,7 +6864,7 @@
                 </a:solidFill>
                 <a:latin typeface="Consolas"/>
               </a:rPr>
-              <a:t>    int opcao = Integer.parseInt(scanner.nextLine().trim());</a:t>
+              <a:t>    int opcao = Integer.parseInt(scanner.nextLine());</a:t>
             </a:r>
           </a:p>
           <a:p>
@@ -6981,7 +6876,7 @@
                 </a:solidFill>
                 <a:latin typeface="Consolas"/>
               </a:rPr>
-              <a:t>    if (opcao &lt; 1 || opcao &gt; 4)</a:t>
+              <a:t>    // executa acao do menu</a:t>
             </a:r>
           </a:p>
           <a:p>
@@ -6993,7 +6888,7 @@
                 </a:solidFill>
                 <a:latin typeface="Consolas"/>
               </a:rPr>
-              <a:t>        throw new EntradaInvalidaException("Opcao invalida.");</a:t>
+              <a:t>} catch (NumberFormatException e) {</a:t>
             </a:r>
           </a:p>
           <a:p>
@@ -7005,7 +6900,7 @@
                 </a:solidFill>
                 <a:latin typeface="Consolas"/>
               </a:rPr>
-              <a:t>    // ... executa a opcao escolhida ...</a:t>
+              <a:t>    System.out.println("Digite apenas numeros.");</a:t>
             </a:r>
           </a:p>
           <a:p>
@@ -7017,7 +6912,7 @@
                 </a:solidFill>
                 <a:latin typeface="Consolas"/>
               </a:rPr>
-              <a:t>} catch (NumberFormatException e) {</a:t>
+              <a:t>} catch (EntradaInvalidaException e) {</a:t>
             </a:r>
           </a:p>
           <a:p>
@@ -7029,31 +6924,7 @@
                 </a:solidFill>
                 <a:latin typeface="Consolas"/>
               </a:rPr>
-              <a:t>    System.out.println("[ERRO] Digite apenas numeros.");</a:t>
-            </a:r>
-          </a:p>
-          <a:p>
-            <a:pPr algn="l"/>
-            <a:r>
-              <a:rPr sz="1150" b="0">
-                <a:solidFill>
-                  <a:srgbClr val="6AD18A"/>
-                </a:solidFill>
-                <a:latin typeface="Consolas"/>
-              </a:rPr>
-              <a:t>} catch (EntradaInvalidaException e) {</a:t>
-            </a:r>
-          </a:p>
-          <a:p>
-            <a:pPr algn="l"/>
-            <a:r>
-              <a:rPr sz="1150" b="0">
-                <a:solidFill>
-                  <a:srgbClr val="6AD18A"/>
-                </a:solidFill>
-                <a:latin typeface="Consolas"/>
-              </a:rPr>
-              <a:t>    System.out.println("[ERRO] " + e.getMessage());</a:t>
+              <a:t>    System.out.println(e.getMessage());</a:t>
             </a:r>
           </a:p>
           <a:p>
@@ -7222,41 +7093,6 @@
       <p:sp>
         <p:nvSpPr>
           <p:cNvPr id="12" name="TextBox 11"/>
-          <p:cNvSpPr txBox="1"/>
-          <p:nvPr/>
-        </p:nvSpPr>
-        <p:spPr>
-          <a:xfrm>
-            <a:off x="457200" y="6446520"/>
-            <a:ext cx="8686800" cy="274320"/>
-          </a:xfrm>
-          <a:prstGeom prst="rect">
-            <a:avLst/>
-          </a:prstGeom>
-          <a:noFill/>
-        </p:spPr>
-        <p:txBody>
-          <a:bodyPr wrap="square" lIns="0" rIns="0" tIns="0" bIns="0" anchor="t">
-            <a:spAutoFit/>
-          </a:bodyPr>
-          <a:lstStyle/>
-          <a:p>
-            <a:pPr algn="l"/>
-            <a:r>
-              <a:rPr sz="900" b="0">
-                <a:solidFill>
-                  <a:srgbClr val="9BB0A0"/>
-                </a:solidFill>
-                <a:latin typeface="Calibri"/>
-              </a:rPr>
-              <a:t>EcoCity  -  RPG Textual  |  APS UNIP 2026/1  -  LPOO</a:t>
-            </a:r>
-          </a:p>
-        </p:txBody>
-      </p:sp>
-      <p:sp>
-        <p:nvSpPr>
-          <p:cNvPr id="13" name="TextBox 12"/>
           <p:cNvSpPr txBox="1"/>
           <p:nvPr/>
         </p:nvSpPr>
@@ -7766,41 +7602,6 @@
         </p:nvSpPr>
         <p:spPr>
           <a:xfrm>
-            <a:off x="457200" y="6446520"/>
-            <a:ext cx="8686800" cy="274320"/>
-          </a:xfrm>
-          <a:prstGeom prst="rect">
-            <a:avLst/>
-          </a:prstGeom>
-          <a:noFill/>
-        </p:spPr>
-        <p:txBody>
-          <a:bodyPr wrap="square" lIns="0" rIns="0" tIns="0" bIns="0" anchor="t">
-            <a:spAutoFit/>
-          </a:bodyPr>
-          <a:lstStyle/>
-          <a:p>
-            <a:pPr algn="l"/>
-            <a:r>
-              <a:rPr sz="900" b="0">
-                <a:solidFill>
-                  <a:srgbClr val="9BB0A0"/>
-                </a:solidFill>
-                <a:latin typeface="Calibri"/>
-              </a:rPr>
-              <a:t>EcoCity  -  RPG Textual  |  APS UNIP 2026/1  -  LPOO</a:t>
-            </a:r>
-          </a:p>
-        </p:txBody>
-      </p:sp>
-      <p:sp>
-        <p:nvSpPr>
-          <p:cNvPr id="13" name="TextBox 12"/>
-          <p:cNvSpPr txBox="1"/>
-          <p:nvPr/>
-        </p:nvSpPr>
-        <p:spPr>
-          <a:xfrm>
             <a:off x="8503920" y="6446520"/>
             <a:ext cx="731520" cy="274320"/>
           </a:xfrm>
@@ -9116,41 +8917,6 @@
         </p:nvSpPr>
         <p:spPr>
           <a:xfrm>
-            <a:off x="457200" y="6446520"/>
-            <a:ext cx="8686800" cy="274320"/>
-          </a:xfrm>
-          <a:prstGeom prst="rect">
-            <a:avLst/>
-          </a:prstGeom>
-          <a:noFill/>
-        </p:spPr>
-        <p:txBody>
-          <a:bodyPr wrap="square" lIns="0" rIns="0" tIns="0" bIns="0" anchor="t">
-            <a:spAutoFit/>
-          </a:bodyPr>
-          <a:lstStyle/>
-          <a:p>
-            <a:pPr algn="l"/>
-            <a:r>
-              <a:rPr sz="900" b="0">
-                <a:solidFill>
-                  <a:srgbClr val="6E7C71"/>
-                </a:solidFill>
-                <a:latin typeface="Calibri"/>
-              </a:rPr>
-              <a:t>EcoCity  -  RPG Textual  |  APS UNIP 2026/1  -  LPOO</a:t>
-            </a:r>
-          </a:p>
-        </p:txBody>
-      </p:sp>
-      <p:sp>
-        <p:nvSpPr>
-          <p:cNvPr id="36" name="TextBox 35"/>
-          <p:cNvSpPr txBox="1"/>
-          <p:nvPr/>
-        </p:nvSpPr>
-        <p:spPr>
-          <a:xfrm>
             <a:off x="8503920" y="6446520"/>
             <a:ext cx="731520" cy="274320"/>
           </a:xfrm>
@@ -10032,41 +9798,6 @@
         </p:nvSpPr>
         <p:spPr>
           <a:xfrm>
-            <a:off x="457200" y="6446520"/>
-            <a:ext cx="8686800" cy="274320"/>
-          </a:xfrm>
-          <a:prstGeom prst="rect">
-            <a:avLst/>
-          </a:prstGeom>
-          <a:noFill/>
-        </p:spPr>
-        <p:txBody>
-          <a:bodyPr wrap="square" lIns="0" rIns="0" tIns="0" bIns="0" anchor="t">
-            <a:spAutoFit/>
-          </a:bodyPr>
-          <a:lstStyle/>
-          <a:p>
-            <a:pPr algn="l"/>
-            <a:r>
-              <a:rPr sz="900" b="0">
-                <a:solidFill>
-                  <a:srgbClr val="6E7C71"/>
-                </a:solidFill>
-                <a:latin typeface="Calibri"/>
-              </a:rPr>
-              <a:t>EcoCity  -  RPG Textual  |  APS UNIP 2026/1  -  LPOO</a:t>
-            </a:r>
-          </a:p>
-        </p:txBody>
-      </p:sp>
-      <p:sp>
-        <p:nvSpPr>
-          <p:cNvPr id="23" name="TextBox 22"/>
-          <p:cNvSpPr txBox="1"/>
-          <p:nvPr/>
-        </p:nvSpPr>
-        <p:spPr>
-          <a:xfrm>
             <a:off x="8503920" y="6446520"/>
             <a:ext cx="731520" cy="274320"/>
           </a:xfrm>
@@ -11058,41 +10789,6 @@
         </p:nvSpPr>
         <p:spPr>
           <a:xfrm>
-            <a:off x="457200" y="6446520"/>
-            <a:ext cx="8686800" cy="274320"/>
-          </a:xfrm>
-          <a:prstGeom prst="rect">
-            <a:avLst/>
-          </a:prstGeom>
-          <a:noFill/>
-        </p:spPr>
-        <p:txBody>
-          <a:bodyPr wrap="square" lIns="0" rIns="0" tIns="0" bIns="0" anchor="t">
-            <a:spAutoFit/>
-          </a:bodyPr>
-          <a:lstStyle/>
-          <a:p>
-            <a:pPr algn="l"/>
-            <a:r>
-              <a:rPr sz="900" b="0">
-                <a:solidFill>
-                  <a:srgbClr val="9BB0A0"/>
-                </a:solidFill>
-                <a:latin typeface="Calibri"/>
-              </a:rPr>
-              <a:t>EcoCity  -  RPG Textual  |  APS UNIP 2026/1  -  LPOO</a:t>
-            </a:r>
-          </a:p>
-        </p:txBody>
-      </p:sp>
-      <p:sp>
-        <p:nvSpPr>
-          <p:cNvPr id="27" name="TextBox 26"/>
-          <p:cNvSpPr txBox="1"/>
-          <p:nvPr/>
-        </p:nvSpPr>
-        <p:spPr>
-          <a:xfrm>
             <a:off x="8503920" y="6446520"/>
             <a:ext cx="731520" cy="274320"/>
           </a:xfrm>
@@ -12048,41 +11744,6 @@
         </p:nvSpPr>
         <p:spPr>
           <a:xfrm>
-            <a:off x="457200" y="6446520"/>
-            <a:ext cx="8686800" cy="274320"/>
-          </a:xfrm>
-          <a:prstGeom prst="rect">
-            <a:avLst/>
-          </a:prstGeom>
-          <a:noFill/>
-        </p:spPr>
-        <p:txBody>
-          <a:bodyPr wrap="square" lIns="0" rIns="0" tIns="0" bIns="0" anchor="t">
-            <a:spAutoFit/>
-          </a:bodyPr>
-          <a:lstStyle/>
-          <a:p>
-            <a:pPr algn="l"/>
-            <a:r>
-              <a:rPr sz="900" b="0">
-                <a:solidFill>
-                  <a:srgbClr val="6E7C71"/>
-                </a:solidFill>
-                <a:latin typeface="Calibri"/>
-              </a:rPr>
-              <a:t>EcoCity  -  RPG Textual  |  APS UNIP 2026/1  -  LPOO</a:t>
-            </a:r>
-          </a:p>
-        </p:txBody>
-      </p:sp>
-      <p:sp>
-        <p:nvSpPr>
-          <p:cNvPr id="26" name="TextBox 25"/>
-          <p:cNvSpPr txBox="1"/>
-          <p:nvPr/>
-        </p:nvSpPr>
-        <p:spPr>
-          <a:xfrm>
             <a:off x="8503920" y="6446520"/>
             <a:ext cx="731520" cy="274320"/>
           </a:xfrm>
@@ -13268,41 +12929,6 @@
         </p:nvSpPr>
         <p:spPr>
           <a:xfrm>
-            <a:off x="457200" y="6446520"/>
-            <a:ext cx="8686800" cy="274320"/>
-          </a:xfrm>
-          <a:prstGeom prst="rect">
-            <a:avLst/>
-          </a:prstGeom>
-          <a:noFill/>
-        </p:spPr>
-        <p:txBody>
-          <a:bodyPr wrap="square" lIns="0" rIns="0" tIns="0" bIns="0" anchor="t">
-            <a:spAutoFit/>
-          </a:bodyPr>
-          <a:lstStyle/>
-          <a:p>
-            <a:pPr algn="l"/>
-            <a:r>
-              <a:rPr sz="900" b="0">
-                <a:solidFill>
-                  <a:srgbClr val="6E7C71"/>
-                </a:solidFill>
-                <a:latin typeface="Calibri"/>
-              </a:rPr>
-              <a:t>EcoCity  -  RPG Textual  |  APS UNIP 2026/1  -  LPOO</a:t>
-            </a:r>
-          </a:p>
-        </p:txBody>
-      </p:sp>
-      <p:sp>
-        <p:nvSpPr>
-          <p:cNvPr id="32" name="TextBox 31"/>
-          <p:cNvSpPr txBox="1"/>
-          <p:nvPr/>
-        </p:nvSpPr>
-        <p:spPr>
-          <a:xfrm>
             <a:off x="8503920" y="6446520"/>
             <a:ext cx="731520" cy="274320"/>
           </a:xfrm>
@@ -14297,41 +13923,6 @@
         </p:nvSpPr>
         <p:spPr>
           <a:xfrm>
-            <a:off x="457200" y="6446520"/>
-            <a:ext cx="8686800" cy="274320"/>
-          </a:xfrm>
-          <a:prstGeom prst="rect">
-            <a:avLst/>
-          </a:prstGeom>
-          <a:noFill/>
-        </p:spPr>
-        <p:txBody>
-          <a:bodyPr wrap="square" lIns="0" rIns="0" tIns="0" bIns="0" anchor="t">
-            <a:spAutoFit/>
-          </a:bodyPr>
-          <a:lstStyle/>
-          <a:p>
-            <a:pPr algn="l"/>
-            <a:r>
-              <a:rPr sz="900" b="0">
-                <a:solidFill>
-                  <a:srgbClr val="6E7C71"/>
-                </a:solidFill>
-                <a:latin typeface="Calibri"/>
-              </a:rPr>
-              <a:t>EcoCity  -  RPG Textual  |  APS UNIP 2026/1  -  LPOO</a:t>
-            </a:r>
-          </a:p>
-        </p:txBody>
-      </p:sp>
-      <p:sp>
-        <p:nvSpPr>
-          <p:cNvPr id="25" name="TextBox 24"/>
-          <p:cNvSpPr txBox="1"/>
-          <p:nvPr/>
-        </p:nvSpPr>
-        <p:spPr>
-          <a:xfrm>
             <a:off x="8503920" y="6446520"/>
             <a:ext cx="731520" cy="274320"/>
           </a:xfrm>
@@ -15171,41 +14762,6 @@
         </p:nvSpPr>
         <p:spPr>
           <a:xfrm>
-            <a:off x="457200" y="6446520"/>
-            <a:ext cx="8686800" cy="274320"/>
-          </a:xfrm>
-          <a:prstGeom prst="rect">
-            <a:avLst/>
-          </a:prstGeom>
-          <a:noFill/>
-        </p:spPr>
-        <p:txBody>
-          <a:bodyPr wrap="square" lIns="0" rIns="0" tIns="0" bIns="0" anchor="t">
-            <a:spAutoFit/>
-          </a:bodyPr>
-          <a:lstStyle/>
-          <a:p>
-            <a:pPr algn="l"/>
-            <a:r>
-              <a:rPr sz="900" b="0">
-                <a:solidFill>
-                  <a:srgbClr val="6E7C71"/>
-                </a:solidFill>
-                <a:latin typeface="Calibri"/>
-              </a:rPr>
-              <a:t>EcoCity  -  RPG Textual  |  APS UNIP 2026/1  -  LPOO</a:t>
-            </a:r>
-          </a:p>
-        </p:txBody>
-      </p:sp>
-      <p:sp>
-        <p:nvSpPr>
-          <p:cNvPr id="23" name="TextBox 22"/>
-          <p:cNvSpPr txBox="1"/>
-          <p:nvPr/>
-        </p:nvSpPr>
-        <p:spPr>
-          <a:xfrm>
             <a:off x="8503920" y="6446520"/>
             <a:ext cx="731520" cy="274320"/>
           </a:xfrm>
@@ -16176,41 +15732,6 @@
       <p:sp>
         <p:nvSpPr>
           <p:cNvPr id="17" name="TextBox 16"/>
-          <p:cNvSpPr txBox="1"/>
-          <p:nvPr/>
-        </p:nvSpPr>
-        <p:spPr>
-          <a:xfrm>
-            <a:off x="457200" y="6446520"/>
-            <a:ext cx="8686800" cy="274320"/>
-          </a:xfrm>
-          <a:prstGeom prst="rect">
-            <a:avLst/>
-          </a:prstGeom>
-          <a:noFill/>
-        </p:spPr>
-        <p:txBody>
-          <a:bodyPr wrap="square" lIns="0" rIns="0" tIns="0" bIns="0" anchor="t">
-            <a:spAutoFit/>
-          </a:bodyPr>
-          <a:lstStyle/>
-          <a:p>
-            <a:pPr algn="l"/>
-            <a:r>
-              <a:rPr sz="900" b="0">
-                <a:solidFill>
-                  <a:srgbClr val="9BB0A0"/>
-                </a:solidFill>
-                <a:latin typeface="Calibri"/>
-              </a:rPr>
-              <a:t>EcoCity  -  RPG Textual  |  APS UNIP 2026/1  -  LPOO</a:t>
-            </a:r>
-          </a:p>
-        </p:txBody>
-      </p:sp>
-      <p:sp>
-        <p:nvSpPr>
-          <p:cNvPr id="18" name="TextBox 17"/>
           <p:cNvSpPr txBox="1"/>
           <p:nvPr/>
         </p:nvSpPr>

</xml_diff>